<commit_message>
Add vcfo as booth sponsor (site, timer, workbook, deck, QR)
</commit_message>
<xml_diff>
--- a/deliverables/deck/Deck.pptx
+++ b/deliverables/deck/Deck.pptx
@@ -3729,8 +3729,8 @@
         </p:blipFill>
         <p:spPr>
           <a:xfrm>
-            <a:off x="747065" y="5878167"/>
-            <a:ext cx="905256" cy="268025"/>
+            <a:off x="747065" y="5892811"/>
+            <a:ext cx="806335" cy="238737"/>
           </a:xfrm>
           <a:prstGeom prst="rect">
             <a:avLst/>
@@ -3753,8 +3753,8 @@
         </p:blipFill>
         <p:spPr>
           <a:xfrm>
-            <a:off x="1835201" y="5905112"/>
-            <a:ext cx="905256" cy="214135"/>
+            <a:off x="1736279" y="5916812"/>
+            <a:ext cx="806335" cy="190736"/>
           </a:xfrm>
           <a:prstGeom prst="rect">
             <a:avLst/>
@@ -3777,8 +3777,8 @@
         </p:blipFill>
         <p:spPr>
           <a:xfrm>
-            <a:off x="2923337" y="5840078"/>
-            <a:ext cx="905256" cy="344204"/>
+            <a:off x="2725494" y="5858884"/>
+            <a:ext cx="806335" cy="306591"/>
           </a:xfrm>
           <a:prstGeom prst="rect">
             <a:avLst/>
@@ -3801,8 +3801,8 @@
         </p:blipFill>
         <p:spPr>
           <a:xfrm>
-            <a:off x="4048563" y="5760720"/>
-            <a:ext cx="831075" cy="502920"/>
+            <a:off x="3714708" y="5768206"/>
+            <a:ext cx="806335" cy="487948"/>
           </a:xfrm>
           <a:prstGeom prst="rect">
             <a:avLst/>
@@ -3825,8 +3825,8 @@
         </p:blipFill>
         <p:spPr>
           <a:xfrm>
-            <a:off x="5099609" y="5942625"/>
-            <a:ext cx="905256" cy="139110"/>
+            <a:off x="4703923" y="5950226"/>
+            <a:ext cx="806335" cy="123908"/>
           </a:xfrm>
           <a:prstGeom prst="rect">
             <a:avLst/>
@@ -3849,8 +3849,8 @@
         </p:blipFill>
         <p:spPr>
           <a:xfrm>
-            <a:off x="6187745" y="5798424"/>
-            <a:ext cx="905256" cy="427512"/>
+            <a:off x="5693138" y="5821782"/>
+            <a:ext cx="806335" cy="380796"/>
           </a:xfrm>
           <a:prstGeom prst="rect">
             <a:avLst/>
@@ -3873,8 +3873,8 @@
         </p:blipFill>
         <p:spPr>
           <a:xfrm>
-            <a:off x="7275881" y="5934874"/>
-            <a:ext cx="905256" cy="154612"/>
+            <a:off x="6682352" y="5943321"/>
+            <a:ext cx="806335" cy="137717"/>
           </a:xfrm>
           <a:prstGeom prst="rect">
             <a:avLst/>
@@ -3897,8 +3897,8 @@
         </p:blipFill>
         <p:spPr>
           <a:xfrm>
-            <a:off x="8364017" y="5920832"/>
-            <a:ext cx="905256" cy="182695"/>
+            <a:off x="7671567" y="5930814"/>
+            <a:ext cx="806335" cy="162731"/>
           </a:xfrm>
           <a:prstGeom prst="rect">
             <a:avLst/>
@@ -3921,8 +3921,8 @@
         </p:blipFill>
         <p:spPr>
           <a:xfrm>
-            <a:off x="9452153" y="5966414"/>
-            <a:ext cx="905256" cy="91532"/>
+            <a:off x="8660781" y="5971415"/>
+            <a:ext cx="806335" cy="81530"/>
           </a:xfrm>
           <a:prstGeom prst="rect">
             <a:avLst/>
@@ -3945,17 +3945,41 @@
         </p:blipFill>
         <p:spPr>
           <a:xfrm>
-            <a:off x="10540289" y="5886363"/>
-            <a:ext cx="905256" cy="251635"/>
+            <a:off x="9649996" y="5900111"/>
+            <a:ext cx="806335" cy="224137"/>
           </a:xfrm>
           <a:prstGeom prst="rect">
             <a:avLst/>
           </a:prstGeom>
         </p:spPr>
       </p:pic>
-      <p:sp>
-        <p:nvSpPr>
-          <p:cNvPr id="24" name="Shape 6"/>
+      <p:pic>
+        <p:nvPicPr>
+          <p:cNvPr id="24" name="Image 16" descr="/home/user/workspace/wroe-dallas-2026/deliverables/workbook/assets/sponsors/vcfo.png">    </p:cNvPr>
+          <p:cNvPicPr>
+            <a:picLocks noChangeAspect="1"/>
+          </p:cNvPicPr>
+          <p:nvPr/>
+        </p:nvPicPr>
+        <p:blipFill>
+          <a:blip r:embed="rId17"/>
+          <a:stretch>
+            <a:fillRect/>
+          </a:stretch>
+        </p:blipFill>
+        <p:spPr>
+          <a:xfrm>
+            <a:off x="10639210" y="5920459"/>
+            <a:ext cx="806335" cy="183441"/>
+          </a:xfrm>
+          <a:prstGeom prst="rect">
+            <a:avLst/>
+          </a:prstGeom>
+        </p:spPr>
+      </p:pic>
+      <p:sp>
+        <p:nvSpPr>
+          <p:cNvPr id="25" name="Shape 6"/>
           <p:cNvSpPr/>
           <p:nvPr/>
         </p:nvSpPr>
@@ -3980,7 +4004,7 @@
       </p:sp>
       <p:sp>
         <p:nvSpPr>
-          <p:cNvPr id="25" name="Text 7"/>
+          <p:cNvPr id="26" name="Text 7"/>
           <p:cNvSpPr/>
           <p:nvPr/>
         </p:nvSpPr>
@@ -4019,7 +4043,7 @@
       </p:sp>
       <p:sp>
         <p:nvSpPr>
-          <p:cNvPr id="26" name="Text 8"/>
+          <p:cNvPr id="27" name="Text 8"/>
           <p:cNvSpPr/>
           <p:nvPr/>
         </p:nvSpPr>
@@ -4821,8 +4845,8 @@
         </p:blipFill>
         <p:spPr>
           <a:xfrm>
-            <a:off x="959434" y="4023360"/>
-            <a:ext cx="2044141" cy="777240"/>
+            <a:off x="701345" y="4029531"/>
+            <a:ext cx="2011680" cy="764897"/>
           </a:xfrm>
           <a:prstGeom prst="rect">
             <a:avLst/>
@@ -4845,7 +4869,7 @@
         </p:blipFill>
         <p:spPr>
           <a:xfrm>
-            <a:off x="4082510" y="4023360"/>
+            <a:off x="3259550" y="4023360"/>
             <a:ext cx="1284389" cy="777240"/>
           </a:xfrm>
           <a:prstGeom prst="rect">
@@ -4869,8 +4893,8 @@
         </p:blipFill>
         <p:spPr>
           <a:xfrm>
-            <a:off x="6187745" y="4215259"/>
-            <a:ext cx="2560320" cy="393441"/>
+            <a:off x="5090465" y="4257414"/>
+            <a:ext cx="2011680" cy="309133"/>
           </a:xfrm>
           <a:prstGeom prst="rect">
             <a:avLst/>
@@ -4893,7 +4917,7 @@
         </p:blipFill>
         <p:spPr>
           <a:xfrm>
-            <a:off x="9388202" y="4023360"/>
+            <a:off x="7467962" y="4023360"/>
             <a:ext cx="1645806" cy="777240"/>
           </a:xfrm>
           <a:prstGeom prst="rect">
@@ -4917,8 +4941,8 @@
         </p:blipFill>
         <p:spPr>
           <a:xfrm>
-            <a:off x="701345" y="5244896"/>
-            <a:ext cx="2560320" cy="437288"/>
+            <a:off x="9479585" y="4240188"/>
+            <a:ext cx="2011680" cy="343583"/>
           </a:xfrm>
           <a:prstGeom prst="rect">
             <a:avLst/>
@@ -4941,8 +4965,8 @@
         </p:blipFill>
         <p:spPr>
           <a:xfrm>
-            <a:off x="3444545" y="5205183"/>
-            <a:ext cx="2560320" cy="516714"/>
+            <a:off x="701345" y="5260545"/>
+            <a:ext cx="2011680" cy="405990"/>
           </a:xfrm>
           <a:prstGeom prst="rect">
             <a:avLst/>
@@ -4965,8 +4989,8 @@
         </p:blipFill>
         <p:spPr>
           <a:xfrm>
-            <a:off x="6187745" y="5334100"/>
-            <a:ext cx="2560320" cy="258880"/>
+            <a:off x="2895905" y="5361837"/>
+            <a:ext cx="2011680" cy="203405"/>
           </a:xfrm>
           <a:prstGeom prst="rect">
             <a:avLst/>
@@ -4989,17 +5013,41 @@
         </p:blipFill>
         <p:spPr>
           <a:xfrm>
-            <a:off x="8930945" y="5107693"/>
-            <a:ext cx="2560320" cy="711694"/>
+            <a:off x="5090465" y="5183946"/>
+            <a:ext cx="2011680" cy="559188"/>
           </a:xfrm>
           <a:prstGeom prst="rect">
             <a:avLst/>
           </a:prstGeom>
         </p:spPr>
       </p:pic>
-      <p:sp>
-        <p:nvSpPr>
-          <p:cNvPr id="16" name="Shape 4"/>
+      <p:pic>
+        <p:nvPicPr>
+          <p:cNvPr id="16" name="Image 10" descr="/home/user/workspace/wroe-dallas-2026/deliverables/workbook/assets/sponsors/vcfo.png">    </p:cNvPr>
+          <p:cNvPicPr>
+            <a:picLocks noChangeAspect="1"/>
+          </p:cNvPicPr>
+          <p:nvPr/>
+        </p:nvPicPr>
+        <p:blipFill>
+          <a:blip r:embed="rId11"/>
+          <a:stretch>
+            <a:fillRect/>
+          </a:stretch>
+        </p:blipFill>
+        <p:spPr>
+          <a:xfrm>
+            <a:off x="7285025" y="5234711"/>
+            <a:ext cx="2011680" cy="457657"/>
+          </a:xfrm>
+          <a:prstGeom prst="rect">
+            <a:avLst/>
+          </a:prstGeom>
+        </p:spPr>
+      </p:pic>
+      <p:sp>
+        <p:nvSpPr>
+          <p:cNvPr id="17" name="Shape 4"/>
           <p:cNvSpPr/>
           <p:nvPr/>
         </p:nvSpPr>
@@ -5024,7 +5072,7 @@
       </p:sp>
       <p:sp>
         <p:nvSpPr>
-          <p:cNvPr id="17" name="Text 5"/>
+          <p:cNvPr id="18" name="Text 5"/>
           <p:cNvSpPr/>
           <p:nvPr/>
         </p:nvSpPr>
@@ -5063,7 +5111,7 @@
       </p:sp>
       <p:sp>
         <p:nvSpPr>
-          <p:cNvPr id="18" name="Text 6"/>
+          <p:cNvPr id="19" name="Text 6"/>
           <p:cNvSpPr/>
           <p:nvPr/>
         </p:nvSpPr>
@@ -9144,8 +9192,8 @@
         </p:blipFill>
         <p:spPr>
           <a:xfrm>
-            <a:off x="747065" y="5878167"/>
-            <a:ext cx="905256" cy="268025"/>
+            <a:off x="747065" y="5892811"/>
+            <a:ext cx="806335" cy="238737"/>
           </a:xfrm>
           <a:prstGeom prst="rect">
             <a:avLst/>
@@ -9168,8 +9216,8 @@
         </p:blipFill>
         <p:spPr>
           <a:xfrm>
-            <a:off x="1835201" y="5905112"/>
-            <a:ext cx="905256" cy="214135"/>
+            <a:off x="1736279" y="5916812"/>
+            <a:ext cx="806335" cy="190736"/>
           </a:xfrm>
           <a:prstGeom prst="rect">
             <a:avLst/>
@@ -9192,8 +9240,8 @@
         </p:blipFill>
         <p:spPr>
           <a:xfrm>
-            <a:off x="2923337" y="5840078"/>
-            <a:ext cx="905256" cy="344204"/>
+            <a:off x="2725494" y="5858884"/>
+            <a:ext cx="806335" cy="306591"/>
           </a:xfrm>
           <a:prstGeom prst="rect">
             <a:avLst/>
@@ -9216,8 +9264,8 @@
         </p:blipFill>
         <p:spPr>
           <a:xfrm>
-            <a:off x="4048563" y="5760720"/>
-            <a:ext cx="831075" cy="502920"/>
+            <a:off x="3714708" y="5768206"/>
+            <a:ext cx="806335" cy="487948"/>
           </a:xfrm>
           <a:prstGeom prst="rect">
             <a:avLst/>
@@ -9240,8 +9288,8 @@
         </p:blipFill>
         <p:spPr>
           <a:xfrm>
-            <a:off x="5099609" y="5942625"/>
-            <a:ext cx="905256" cy="139110"/>
+            <a:off x="4703923" y="5950226"/>
+            <a:ext cx="806335" cy="123908"/>
           </a:xfrm>
           <a:prstGeom prst="rect">
             <a:avLst/>
@@ -9264,8 +9312,8 @@
         </p:blipFill>
         <p:spPr>
           <a:xfrm>
-            <a:off x="6187745" y="5798424"/>
-            <a:ext cx="905256" cy="427512"/>
+            <a:off x="5693138" y="5821782"/>
+            <a:ext cx="806335" cy="380796"/>
           </a:xfrm>
           <a:prstGeom prst="rect">
             <a:avLst/>
@@ -9288,8 +9336,8 @@
         </p:blipFill>
         <p:spPr>
           <a:xfrm>
-            <a:off x="7275881" y="5934874"/>
-            <a:ext cx="905256" cy="154612"/>
+            <a:off x="6682352" y="5943321"/>
+            <a:ext cx="806335" cy="137717"/>
           </a:xfrm>
           <a:prstGeom prst="rect">
             <a:avLst/>
@@ -9312,8 +9360,8 @@
         </p:blipFill>
         <p:spPr>
           <a:xfrm>
-            <a:off x="8364017" y="5920832"/>
-            <a:ext cx="905256" cy="182695"/>
+            <a:off x="7671567" y="5930814"/>
+            <a:ext cx="806335" cy="162731"/>
           </a:xfrm>
           <a:prstGeom prst="rect">
             <a:avLst/>
@@ -9336,8 +9384,8 @@
         </p:blipFill>
         <p:spPr>
           <a:xfrm>
-            <a:off x="9452153" y="5966414"/>
-            <a:ext cx="905256" cy="91532"/>
+            <a:off x="8660781" y="5971415"/>
+            <a:ext cx="806335" cy="81530"/>
           </a:xfrm>
           <a:prstGeom prst="rect">
             <a:avLst/>
@@ -9360,17 +9408,41 @@
         </p:blipFill>
         <p:spPr>
           <a:xfrm>
-            <a:off x="10540289" y="5886363"/>
-            <a:ext cx="905256" cy="251635"/>
+            <a:off x="9649996" y="5900111"/>
+            <a:ext cx="806335" cy="224137"/>
           </a:xfrm>
           <a:prstGeom prst="rect">
             <a:avLst/>
           </a:prstGeom>
         </p:spPr>
       </p:pic>
-      <p:sp>
-        <p:nvSpPr>
-          <p:cNvPr id="24" name="Shape 6"/>
+      <p:pic>
+        <p:nvPicPr>
+          <p:cNvPr id="24" name="Image 16" descr="/home/user/workspace/wroe-dallas-2026/deliverables/workbook/assets/sponsors/vcfo.png">    </p:cNvPr>
+          <p:cNvPicPr>
+            <a:picLocks noChangeAspect="1"/>
+          </p:cNvPicPr>
+          <p:nvPr/>
+        </p:nvPicPr>
+        <p:blipFill>
+          <a:blip r:embed="rId17"/>
+          <a:stretch>
+            <a:fillRect/>
+          </a:stretch>
+        </p:blipFill>
+        <p:spPr>
+          <a:xfrm>
+            <a:off x="10639210" y="5920459"/>
+            <a:ext cx="806335" cy="183441"/>
+          </a:xfrm>
+          <a:prstGeom prst="rect">
+            <a:avLst/>
+          </a:prstGeom>
+        </p:spPr>
+      </p:pic>
+      <p:sp>
+        <p:nvSpPr>
+          <p:cNvPr id="25" name="Shape 6"/>
           <p:cNvSpPr/>
           <p:nvPr/>
         </p:nvSpPr>
@@ -9395,7 +9467,7 @@
       </p:sp>
       <p:sp>
         <p:nvSpPr>
-          <p:cNvPr id="25" name="Text 7"/>
+          <p:cNvPr id="26" name="Text 7"/>
           <p:cNvSpPr/>
           <p:nvPr/>
         </p:nvSpPr>
@@ -9434,7 +9506,7 @@
       </p:sp>
       <p:sp>
         <p:nvSpPr>
-          <p:cNvPr id="26" name="Text 8"/>
+          <p:cNvPr id="27" name="Text 8"/>
           <p:cNvSpPr/>
           <p:nvPr/>
         </p:nvSpPr>

</xml_diff>

<commit_message>
Deck: real venue WiFi credentials (Hilton Honors Meeting / Traction)
</commit_message>
<xml_diff>
--- a/deliverables/deck/Deck.pptx
+++ b/deliverables/deck/Deck.pptx
@@ -1321,7 +1321,7 @@
           <a:p>
             <a:r>
               <a:rPr lang="en-US" dirty="0"/>
-              <a:t>[Pre-event loop — no emcee needed. Placeholder Wi-Fi credentials — replace with actual venue values before event day.]</a:t>
+              <a:t>[Pre-event loop — no emcee needed. Confirmed venue Wi-Fi credentials.]</a:t>
             </a:r>
             <a:endParaRPr lang="en-US" dirty="0"/>
           </a:p>
@@ -6516,7 +6516,7 @@
                 <a:ea typeface="Calibri" pitchFamily="34" charset="-122"/>
                 <a:cs typeface="Calibri" pitchFamily="34" charset="-120"/>
               </a:rPr>
-              <a:t>WRoEOS-Guest</a:t>
+              <a:t>Hilton Honors Meeting</a:t>
             </a:r>
             <a:endParaRPr lang="en-US" sz="3200" dirty="0"/>
           </a:p>
@@ -6621,7 +6621,7 @@
                 <a:ea typeface="Calibri" pitchFamily="34" charset="-122"/>
                 <a:cs typeface="Calibri" pitchFamily="34" charset="-120"/>
               </a:rPr>
-              <a:t>RunOnEOS2026</a:t>
+              <a:t>Traction</a:t>
             </a:r>
             <a:endParaRPr lang="en-US" sz="3200" dirty="0"/>
           </a:p>

</xml_diff>

<commit_message>
Deck WiFi slide: add scan-to-join QR code
</commit_message>
<xml_diff>
--- a/deliverables/deck/Deck.pptx
+++ b/deliverables/deck/Deck.pptx
@@ -1321,7 +1321,7 @@
           <a:p>
             <a:r>
               <a:rPr lang="en-US" dirty="0"/>
-              <a:t>[Pre-event loop — no emcee needed. Confirmed venue Wi-Fi credentials.]</a:t>
+              <a:t>[Pre-event loop — no emcee needed. Confirmed venue Wi-Fi credentials. QR encodes WIFI:T:WPA;S:Hilton Honors Meeting;P:Traction;; — works on iOS and Android camera apps.]</a:t>
             </a:r>
             <a:endParaRPr lang="en-US" dirty="0"/>
           </a:p>
@@ -6425,8 +6425,8 @@
         </p:nvSpPr>
         <p:spPr>
           <a:xfrm>
-            <a:off x="3200400" y="2926080"/>
-            <a:ext cx="5790895" cy="1005840"/>
+            <a:off x="1280160" y="2926080"/>
+            <a:ext cx="6035040" cy="1005840"/>
           </a:xfrm>
           <a:prstGeom prst="roundRect">
             <a:avLst>
@@ -6452,8 +6452,8 @@
         </p:nvSpPr>
         <p:spPr>
           <a:xfrm>
-            <a:off x="3383280" y="3017520"/>
-            <a:ext cx="5486400" cy="274320"/>
+            <a:off x="1463040" y="3017520"/>
+            <a:ext cx="5669280" cy="274320"/>
           </a:xfrm>
           <a:prstGeom prst="rect">
             <a:avLst/>
@@ -6491,8 +6491,8 @@
         </p:nvSpPr>
         <p:spPr>
           <a:xfrm>
-            <a:off x="3383280" y="3337560"/>
-            <a:ext cx="5486400" cy="502920"/>
+            <a:off x="1463040" y="3337560"/>
+            <a:ext cx="5669280" cy="502920"/>
           </a:xfrm>
           <a:prstGeom prst="rect">
             <a:avLst/>
@@ -6508,7 +6508,7 @@
               <a:buNone/>
             </a:pPr>
             <a:r>
-              <a:rPr lang="en-US" sz="3200" b="1" dirty="0">
+              <a:rPr lang="en-US" sz="2800" b="1" dirty="0">
                 <a:solidFill>
                   <a:srgbClr val="FFFFFF"/>
                 </a:solidFill>
@@ -6518,7 +6518,7 @@
               </a:rPr>
               <a:t>Hilton Honors Meeting</a:t>
             </a:r>
-            <a:endParaRPr lang="en-US" sz="3200" dirty="0"/>
+            <a:endParaRPr lang="en-US" sz="2800" dirty="0"/>
           </a:p>
         </p:txBody>
       </p:sp>
@@ -6530,8 +6530,8 @@
         </p:nvSpPr>
         <p:spPr>
           <a:xfrm>
-            <a:off x="3200400" y="4114800"/>
-            <a:ext cx="5790895" cy="1005840"/>
+            <a:off x="1280160" y="4114800"/>
+            <a:ext cx="6035040" cy="1005840"/>
           </a:xfrm>
           <a:prstGeom prst="roundRect">
             <a:avLst>
@@ -6557,8 +6557,8 @@
         </p:nvSpPr>
         <p:spPr>
           <a:xfrm>
-            <a:off x="3383280" y="4206240"/>
-            <a:ext cx="5486400" cy="274320"/>
+            <a:off x="1463040" y="4206240"/>
+            <a:ext cx="5669280" cy="274320"/>
           </a:xfrm>
           <a:prstGeom prst="rect">
             <a:avLst/>
@@ -6596,8 +6596,8 @@
         </p:nvSpPr>
         <p:spPr>
           <a:xfrm>
-            <a:off x="3383280" y="4526280"/>
-            <a:ext cx="5486400" cy="502920"/>
+            <a:off x="1463040" y="4526280"/>
+            <a:ext cx="5669280" cy="502920"/>
           </a:xfrm>
           <a:prstGeom prst="rect">
             <a:avLst/>
@@ -6613,7 +6613,7 @@
               <a:buNone/>
             </a:pPr>
             <a:r>
-              <a:rPr lang="en-US" sz="3200" b="1" dirty="0">
+              <a:rPr lang="en-US" sz="2800" b="1" dirty="0">
                 <a:solidFill>
                   <a:srgbClr val="FFFFFF"/>
                 </a:solidFill>
@@ -6623,13 +6623,103 @@
               </a:rPr>
               <a:t>Traction</a:t>
             </a:r>
-            <a:endParaRPr lang="en-US" sz="3200" dirty="0"/>
+            <a:endParaRPr lang="en-US" sz="2800" dirty="0"/>
           </a:p>
         </p:txBody>
       </p:sp>
       <p:sp>
         <p:nvSpPr>
           <p:cNvPr id="10" name="Shape 8"/>
+          <p:cNvSpPr/>
+          <p:nvPr/>
+        </p:nvSpPr>
+        <p:spPr>
+          <a:xfrm>
+            <a:off x="7909560" y="2926080"/>
+            <a:ext cx="2468880" cy="2468880"/>
+          </a:xfrm>
+          <a:prstGeom prst="roundRect">
+            <a:avLst>
+              <a:gd name="adj" fmla="val 3704"/>
+            </a:avLst>
+          </a:prstGeom>
+          <a:solidFill>
+            <a:srgbClr val="FFFFFF"/>
+          </a:solidFill>
+          <a:ln w="12700">
+            <a:solidFill>
+              <a:srgbClr val="E87722"/>
+            </a:solidFill>
+            <a:prstDash val="solid"/>
+          </a:ln>
+        </p:spPr>
+      </p:sp>
+      <p:pic>
+        <p:nvPicPr>
+          <p:cNvPr id="11" name="Image 0" descr="wifi_qr.png">    </p:cNvPr>
+          <p:cNvPicPr>
+            <a:picLocks noChangeAspect="1"/>
+          </p:cNvPicPr>
+          <p:nvPr/>
+        </p:nvPicPr>
+        <p:blipFill>
+          <a:blip r:embed="rId1"/>
+          <a:stretch>
+            <a:fillRect/>
+          </a:stretch>
+        </p:blipFill>
+        <p:spPr>
+          <a:xfrm>
+            <a:off x="8092440" y="3108960"/>
+            <a:ext cx="2103120" cy="2103120"/>
+          </a:xfrm>
+          <a:prstGeom prst="rect">
+            <a:avLst/>
+          </a:prstGeom>
+        </p:spPr>
+      </p:pic>
+      <p:sp>
+        <p:nvSpPr>
+          <p:cNvPr id="12" name="Text 9"/>
+          <p:cNvSpPr/>
+          <p:nvPr/>
+        </p:nvSpPr>
+        <p:spPr>
+          <a:xfrm>
+            <a:off x="7909560" y="5486400"/>
+            <a:ext cx="2468880" cy="274320"/>
+          </a:xfrm>
+          <a:prstGeom prst="rect">
+            <a:avLst/>
+          </a:prstGeom>
+          <a:noFill/>
+          <a:ln/>
+        </p:spPr>
+        <p:txBody>
+          <a:bodyPr wrap="square" rtlCol="0" anchor="ctr"/>
+          <a:lstStyle/>
+          <a:p>
+            <a:pPr algn="ctr" indent="0" marL="0">
+              <a:buNone/>
+            </a:pPr>
+            <a:r>
+              <a:rPr lang="en-US" sz="1100" b="1" spc="600" kern="0" dirty="0">
+                <a:solidFill>
+                  <a:srgbClr val="E87722"/>
+                </a:solidFill>
+                <a:latin typeface="Calibri" pitchFamily="34" charset="0"/>
+                <a:ea typeface="Calibri" pitchFamily="34" charset="-122"/>
+                <a:cs typeface="Calibri" pitchFamily="34" charset="-120"/>
+              </a:rPr>
+              <a:t>SCAN TO JOIN</a:t>
+            </a:r>
+            <a:endParaRPr lang="en-US" sz="1100" dirty="0"/>
+          </a:p>
+        </p:txBody>
+      </p:sp>
+      <p:sp>
+        <p:nvSpPr>
+          <p:cNvPr id="13" name="Shape 10"/>
           <p:cNvSpPr/>
           <p:nvPr/>
         </p:nvSpPr>
@@ -6654,7 +6744,7 @@
       </p:sp>
       <p:sp>
         <p:nvSpPr>
-          <p:cNvPr id="11" name="Text 9"/>
+          <p:cNvPr id="14" name="Text 11"/>
           <p:cNvSpPr/>
           <p:nvPr/>
         </p:nvSpPr>
@@ -6693,7 +6783,7 @@
       </p:sp>
       <p:sp>
         <p:nvSpPr>
-          <p:cNvPr id="12" name="Text 10"/>
+          <p:cNvPr id="15" name="Text 12"/>
           <p:cNvSpPr/>
           <p:nvPr/>
         </p:nvSpPr>

</xml_diff>